<commit_message>
Add Al Khobar branch to summary slide template
Adds a fifth branch row (Al Khobar / prefix AK) to the blank PPTX
template's summary slide, inserted below Hittin with the same row
geometry (256032 EMU gap). The Cluster Utilization footer shifts down
by one row gap and the branch count updates from 4 → 5 branches.

The tokenizer auto-assigns {{AK_CLINIC}}, {{AK_TARGET}}, {{AK_ER}},
{{AK_TOTAL}}, {{AK_RATE}} tokens to the new row, so Al Khobar now
appears in the branch assignment dropdown and summary table.
</commit_message>
<xml_diff>
--- a/template/Cluster2_Daily_Report_BLANK_Template.pptx
+++ b/template/Cluster2_Daily_Report_BLANK_Template.pptx
@@ -3116,13 +3116,273 @@
       </p:sp>
       <p:sp>
         <p:nvSpPr>
+          <p:cNvPr id="65" name="Text 62"/>
+          <p:cNvSpPr/>
+          <p:nvPr/>
+        </p:nvSpPr>
+        <p:spPr>
+          <a:xfrm>
+            <a:off x="457200" y="3950208"/>
+            <a:ext cx="2240280" cy="256032"/>
+          </a:xfrm>
+          <a:prstGeom prst="rect">
+            <a:avLst/>
+          </a:prstGeom>
+          <a:noFill/>
+          <a:ln/>
+        </p:spPr>
+        <p:txBody>
+          <a:bodyPr wrap="square" lIns="0" tIns="0" rIns="0" bIns="0" rtlCol="0" anchor="ctr"/>
+          <a:lstStyle/>
+          <a:p>
+            <a:pPr indent="0" marL="0">
+              <a:buNone/>
+            </a:pPr>
+            <a:r>
+              <a:rPr lang="en-US" sz="1000" b="1" dirty="0">
+                <a:solidFill>
+                  <a:srgbClr val="1E1A33"/>
+                </a:solidFill>
+                <a:latin typeface="Times New Roman" pitchFamily="34" charset="0"/>
+                <a:ea typeface="Times New Roman" pitchFamily="34" charset="-122"/>
+                <a:cs typeface="Times New Roman" pitchFamily="34" charset="-120"/>
+              </a:rPr>
+              <a:t>Al Khobar</a:t>
+            </a:r>
+            <a:endParaRPr lang="en-US" sz="1000" dirty="0"/>
+          </a:p>
+        </p:txBody>
+      </p:sp>
+      <p:sp>
+        <p:nvSpPr>
+          <p:cNvPr id="66" name="Text 63"/>
+          <p:cNvSpPr/>
+          <p:nvPr/>
+        </p:nvSpPr>
+        <p:spPr>
+          <a:xfrm>
+            <a:off x="2697480" y="3950208"/>
+            <a:ext cx="1234440" cy="256032"/>
+          </a:xfrm>
+          <a:prstGeom prst="rect">
+            <a:avLst/>
+          </a:prstGeom>
+          <a:noFill/>
+          <a:ln/>
+        </p:spPr>
+        <p:txBody>
+          <a:bodyPr wrap="square" lIns="0" tIns="0" rIns="0" bIns="0" rtlCol="0" anchor="ctr"/>
+          <a:lstStyle/>
+          <a:p>
+            <a:pPr algn="ctr" indent="0" marL="0">
+              <a:buNone/>
+            </a:pPr>
+            <a:r>
+              <a:rPr lang="en-US" sz="1000" dirty="0">
+                <a:solidFill>
+                  <a:srgbClr val="5A5470"/>
+                </a:solidFill>
+                <a:latin typeface="Times New Roman" pitchFamily="34" charset="0"/>
+                <a:ea typeface="Times New Roman" pitchFamily="34" charset="-122"/>
+                <a:cs typeface="Times New Roman" pitchFamily="34" charset="-120"/>
+              </a:rPr>
+              <a:t>—</a:t>
+            </a:r>
+            <a:endParaRPr lang="en-US" sz="1000" dirty="0"/>
+          </a:p>
+        </p:txBody>
+      </p:sp>
+      <p:sp>
+        <p:nvSpPr>
+          <p:cNvPr id="67" name="Text 64"/>
+          <p:cNvSpPr/>
+          <p:nvPr/>
+        </p:nvSpPr>
+        <p:spPr>
+          <a:xfrm>
+            <a:off x="3931920" y="3950208"/>
+            <a:ext cx="1234440" cy="256032"/>
+          </a:xfrm>
+          <a:prstGeom prst="rect">
+            <a:avLst/>
+          </a:prstGeom>
+          <a:noFill/>
+          <a:ln/>
+        </p:spPr>
+        <p:txBody>
+          <a:bodyPr wrap="square" lIns="0" tIns="0" rIns="0" bIns="0" rtlCol="0" anchor="ctr"/>
+          <a:lstStyle/>
+          <a:p>
+            <a:pPr algn="ctr" indent="0" marL="0">
+              <a:buNone/>
+            </a:pPr>
+            <a:r>
+              <a:rPr lang="en-US" sz="1000" dirty="0">
+                <a:solidFill>
+                  <a:srgbClr val="5A5470"/>
+                </a:solidFill>
+                <a:latin typeface="Times New Roman" pitchFamily="34" charset="0"/>
+                <a:ea typeface="Times New Roman" pitchFamily="34" charset="-122"/>
+                <a:cs typeface="Times New Roman" pitchFamily="34" charset="-120"/>
+              </a:rPr>
+              <a:t>—</a:t>
+            </a:r>
+            <a:endParaRPr lang="en-US" sz="1000" dirty="0"/>
+          </a:p>
+        </p:txBody>
+      </p:sp>
+      <p:sp>
+        <p:nvSpPr>
+          <p:cNvPr id="68" name="Text 65"/>
+          <p:cNvSpPr/>
+          <p:nvPr/>
+        </p:nvSpPr>
+        <p:spPr>
+          <a:xfrm>
+            <a:off x="5166360" y="3950208"/>
+            <a:ext cx="1234440" cy="256032"/>
+          </a:xfrm>
+          <a:prstGeom prst="rect">
+            <a:avLst/>
+          </a:prstGeom>
+          <a:noFill/>
+          <a:ln/>
+        </p:spPr>
+        <p:txBody>
+          <a:bodyPr wrap="square" lIns="0" tIns="0" rIns="0" bIns="0" rtlCol="0" anchor="ctr"/>
+          <a:lstStyle/>
+          <a:p>
+            <a:pPr algn="ctr" indent="0" marL="0">
+              <a:buNone/>
+            </a:pPr>
+            <a:r>
+              <a:rPr lang="en-US" sz="1000" dirty="0">
+                <a:solidFill>
+                  <a:srgbClr val="5A5470"/>
+                </a:solidFill>
+                <a:latin typeface="Times New Roman" pitchFamily="34" charset="0"/>
+                <a:ea typeface="Times New Roman" pitchFamily="34" charset="-122"/>
+                <a:cs typeface="Times New Roman" pitchFamily="34" charset="-120"/>
+              </a:rPr>
+              <a:t>—</a:t>
+            </a:r>
+            <a:endParaRPr lang="en-US" sz="1000" dirty="0"/>
+          </a:p>
+        </p:txBody>
+      </p:sp>
+      <p:sp>
+        <p:nvSpPr>
+          <p:cNvPr id="69" name="Text 66"/>
+          <p:cNvSpPr/>
+          <p:nvPr/>
+        </p:nvSpPr>
+        <p:spPr>
+          <a:xfrm>
+            <a:off x="6400800" y="3950208"/>
+            <a:ext cx="1234440" cy="256032"/>
+          </a:xfrm>
+          <a:prstGeom prst="rect">
+            <a:avLst/>
+          </a:prstGeom>
+          <a:noFill/>
+          <a:ln/>
+        </p:spPr>
+        <p:txBody>
+          <a:bodyPr wrap="square" lIns="0" tIns="0" rIns="0" bIns="0" rtlCol="0" anchor="ctr"/>
+          <a:lstStyle/>
+          <a:p>
+            <a:pPr algn="ctr" indent="0" marL="0">
+              <a:buNone/>
+            </a:pPr>
+            <a:r>
+              <a:rPr lang="en-US" sz="1000" dirty="0">
+                <a:solidFill>
+                  <a:srgbClr val="5A5470"/>
+                </a:solidFill>
+                <a:latin typeface="Times New Roman" pitchFamily="34" charset="0"/>
+                <a:ea typeface="Times New Roman" pitchFamily="34" charset="-122"/>
+                <a:cs typeface="Times New Roman" pitchFamily="34" charset="-120"/>
+              </a:rPr>
+              <a:t>—</a:t>
+            </a:r>
+            <a:endParaRPr lang="en-US" sz="1000" dirty="0"/>
+          </a:p>
+        </p:txBody>
+      </p:sp>
+      <p:sp>
+        <p:nvSpPr>
+          <p:cNvPr id="70" name="Shape 67"/>
+          <p:cNvSpPr/>
+          <p:nvPr/>
+        </p:nvSpPr>
+        <p:spPr>
+          <a:xfrm>
+            <a:off x="7882128" y="3991356"/>
+            <a:ext cx="694944" cy="173736"/>
+          </a:xfrm>
+          <a:prstGeom prst="roundRect">
+            <a:avLst>
+              <a:gd name="adj" fmla="val 47368"/>
+            </a:avLst>
+          </a:prstGeom>
+          <a:solidFill>
+            <a:srgbClr val="D7D2E9"/>
+          </a:solidFill>
+          <a:ln/>
+        </p:spPr>
+        <p:txBody>
+          <a:bodyPr/>
+          <a:p/>
+        </p:txBody>
+      </p:sp>
+      <p:sp>
+        <p:nvSpPr>
+          <p:cNvPr id="71" name="Text 68"/>
+          <p:cNvSpPr/>
+          <p:nvPr/>
+        </p:nvSpPr>
+        <p:spPr>
+          <a:xfrm>
+            <a:off x="7882128" y="3991356"/>
+            <a:ext cx="694944" cy="173736"/>
+          </a:xfrm>
+          <a:prstGeom prst="rect">
+            <a:avLst/>
+          </a:prstGeom>
+          <a:noFill/>
+          <a:ln/>
+        </p:spPr>
+        <p:txBody>
+          <a:bodyPr wrap="square" lIns="0" tIns="0" rIns="0" bIns="0" rtlCol="0" anchor="ctr"/>
+          <a:lstStyle/>
+          <a:p>
+            <a:pPr algn="ctr" indent="0" marL="0">
+              <a:buNone/>
+            </a:pPr>
+            <a:r>
+              <a:rPr lang="en-US" sz="900" b="1" dirty="0">
+                <a:solidFill>
+                  <a:srgbClr val="5A5470"/>
+                </a:solidFill>
+                <a:latin typeface="Plus Jakarta Sans" pitchFamily="34" charset="0"/>
+                <a:ea typeface="Plus Jakarta Sans" pitchFamily="34" charset="-122"/>
+                <a:cs typeface="Plus Jakarta Sans" pitchFamily="34" charset="-120"/>
+              </a:rPr>
+              <a:t>—</a:t>
+            </a:r>
+            <a:endParaRPr lang="en-US" sz="900" dirty="0"/>
+          </a:p>
+        </p:txBody>
+      </p:sp>
+      <p:sp>
+        <p:nvSpPr>
           <p:cNvPr id="61" name="Shape 58"/>
           <p:cNvSpPr/>
           <p:nvPr/>
         </p:nvSpPr>
         <p:spPr>
           <a:xfrm>
-            <a:off x="320040" y="4114800"/>
+            <a:off x="320040" y="4370832"/>
             <a:ext cx="8503920" cy="502920"/>
           </a:xfrm>
           <a:prstGeom prst="roundRect">
@@ -3148,7 +3408,7 @@
         </p:nvSpPr>
         <p:spPr>
           <a:xfrm>
-            <a:off x="548640" y="4114800"/>
+            <a:off x="548640" y="4370832"/>
             <a:ext cx="8046720" cy="502920"/>
           </a:xfrm>
           <a:prstGeom prst="rect">
@@ -3201,7 +3461,7 @@
                 <a:ea typeface="Plus Jakarta Sans" pitchFamily="34" charset="-122"/>
                 <a:cs typeface="Plus Jakarta Sans" pitchFamily="34" charset="-120"/>
               </a:rPr>
-              <a:t>Actual — / Target — · 4 branches · Clinic basis</a:t>
+              <a:t>Actual — / Target — · 5 branches · Clinic basis</a:t>
             </a:r>
             <a:endParaRPr lang="en-US" sz="1200" dirty="0"/>
           </a:p>

</xml_diff>

<commit_message>
Move Al Khobar branch to a dedicated khobar.html page
- Revert index.html template to 4 branches (Al Worood, Al Suwaydi,
  Al Qirawan, Hittin) — Al Khobar removed from the main page
- Add Cluster5_AlKhobar_Template.pptx: 5-branch template that includes
  Al Khobar below Hittin with {{AK_*}} tokens
- Generate khobar.html from this template via build_pages.py
  → live at /Aogh/khobar.html
</commit_message>
<xml_diff>
--- a/template/Cluster2_Daily_Report_BLANK_Template.pptx
+++ b/template/Cluster2_Daily_Report_BLANK_Template.pptx
@@ -3116,273 +3116,13 @@
       </p:sp>
       <p:sp>
         <p:nvSpPr>
-          <p:cNvPr id="65" name="Text 62"/>
-          <p:cNvSpPr/>
-          <p:nvPr/>
-        </p:nvSpPr>
-        <p:spPr>
-          <a:xfrm>
-            <a:off x="457200" y="3950208"/>
-            <a:ext cx="2240280" cy="256032"/>
-          </a:xfrm>
-          <a:prstGeom prst="rect">
-            <a:avLst/>
-          </a:prstGeom>
-          <a:noFill/>
-          <a:ln/>
-        </p:spPr>
-        <p:txBody>
-          <a:bodyPr wrap="square" lIns="0" tIns="0" rIns="0" bIns="0" rtlCol="0" anchor="ctr"/>
-          <a:lstStyle/>
-          <a:p>
-            <a:pPr indent="0" marL="0">
-              <a:buNone/>
-            </a:pPr>
-            <a:r>
-              <a:rPr lang="en-US" sz="1000" b="1" dirty="0">
-                <a:solidFill>
-                  <a:srgbClr val="1E1A33"/>
-                </a:solidFill>
-                <a:latin typeface="Times New Roman" pitchFamily="34" charset="0"/>
-                <a:ea typeface="Times New Roman" pitchFamily="34" charset="-122"/>
-                <a:cs typeface="Times New Roman" pitchFamily="34" charset="-120"/>
-              </a:rPr>
-              <a:t>Al Khobar</a:t>
-            </a:r>
-            <a:endParaRPr lang="en-US" sz="1000" dirty="0"/>
-          </a:p>
-        </p:txBody>
-      </p:sp>
-      <p:sp>
-        <p:nvSpPr>
-          <p:cNvPr id="66" name="Text 63"/>
-          <p:cNvSpPr/>
-          <p:nvPr/>
-        </p:nvSpPr>
-        <p:spPr>
-          <a:xfrm>
-            <a:off x="2697480" y="3950208"/>
-            <a:ext cx="1234440" cy="256032"/>
-          </a:xfrm>
-          <a:prstGeom prst="rect">
-            <a:avLst/>
-          </a:prstGeom>
-          <a:noFill/>
-          <a:ln/>
-        </p:spPr>
-        <p:txBody>
-          <a:bodyPr wrap="square" lIns="0" tIns="0" rIns="0" bIns="0" rtlCol="0" anchor="ctr"/>
-          <a:lstStyle/>
-          <a:p>
-            <a:pPr algn="ctr" indent="0" marL="0">
-              <a:buNone/>
-            </a:pPr>
-            <a:r>
-              <a:rPr lang="en-US" sz="1000" dirty="0">
-                <a:solidFill>
-                  <a:srgbClr val="5A5470"/>
-                </a:solidFill>
-                <a:latin typeface="Times New Roman" pitchFamily="34" charset="0"/>
-                <a:ea typeface="Times New Roman" pitchFamily="34" charset="-122"/>
-                <a:cs typeface="Times New Roman" pitchFamily="34" charset="-120"/>
-              </a:rPr>
-              <a:t>—</a:t>
-            </a:r>
-            <a:endParaRPr lang="en-US" sz="1000" dirty="0"/>
-          </a:p>
-        </p:txBody>
-      </p:sp>
-      <p:sp>
-        <p:nvSpPr>
-          <p:cNvPr id="67" name="Text 64"/>
-          <p:cNvSpPr/>
-          <p:nvPr/>
-        </p:nvSpPr>
-        <p:spPr>
-          <a:xfrm>
-            <a:off x="3931920" y="3950208"/>
-            <a:ext cx="1234440" cy="256032"/>
-          </a:xfrm>
-          <a:prstGeom prst="rect">
-            <a:avLst/>
-          </a:prstGeom>
-          <a:noFill/>
-          <a:ln/>
-        </p:spPr>
-        <p:txBody>
-          <a:bodyPr wrap="square" lIns="0" tIns="0" rIns="0" bIns="0" rtlCol="0" anchor="ctr"/>
-          <a:lstStyle/>
-          <a:p>
-            <a:pPr algn="ctr" indent="0" marL="0">
-              <a:buNone/>
-            </a:pPr>
-            <a:r>
-              <a:rPr lang="en-US" sz="1000" dirty="0">
-                <a:solidFill>
-                  <a:srgbClr val="5A5470"/>
-                </a:solidFill>
-                <a:latin typeface="Times New Roman" pitchFamily="34" charset="0"/>
-                <a:ea typeface="Times New Roman" pitchFamily="34" charset="-122"/>
-                <a:cs typeface="Times New Roman" pitchFamily="34" charset="-120"/>
-              </a:rPr>
-              <a:t>—</a:t>
-            </a:r>
-            <a:endParaRPr lang="en-US" sz="1000" dirty="0"/>
-          </a:p>
-        </p:txBody>
-      </p:sp>
-      <p:sp>
-        <p:nvSpPr>
-          <p:cNvPr id="68" name="Text 65"/>
-          <p:cNvSpPr/>
-          <p:nvPr/>
-        </p:nvSpPr>
-        <p:spPr>
-          <a:xfrm>
-            <a:off x="5166360" y="3950208"/>
-            <a:ext cx="1234440" cy="256032"/>
-          </a:xfrm>
-          <a:prstGeom prst="rect">
-            <a:avLst/>
-          </a:prstGeom>
-          <a:noFill/>
-          <a:ln/>
-        </p:spPr>
-        <p:txBody>
-          <a:bodyPr wrap="square" lIns="0" tIns="0" rIns="0" bIns="0" rtlCol="0" anchor="ctr"/>
-          <a:lstStyle/>
-          <a:p>
-            <a:pPr algn="ctr" indent="0" marL="0">
-              <a:buNone/>
-            </a:pPr>
-            <a:r>
-              <a:rPr lang="en-US" sz="1000" dirty="0">
-                <a:solidFill>
-                  <a:srgbClr val="5A5470"/>
-                </a:solidFill>
-                <a:latin typeface="Times New Roman" pitchFamily="34" charset="0"/>
-                <a:ea typeface="Times New Roman" pitchFamily="34" charset="-122"/>
-                <a:cs typeface="Times New Roman" pitchFamily="34" charset="-120"/>
-              </a:rPr>
-              <a:t>—</a:t>
-            </a:r>
-            <a:endParaRPr lang="en-US" sz="1000" dirty="0"/>
-          </a:p>
-        </p:txBody>
-      </p:sp>
-      <p:sp>
-        <p:nvSpPr>
-          <p:cNvPr id="69" name="Text 66"/>
-          <p:cNvSpPr/>
-          <p:nvPr/>
-        </p:nvSpPr>
-        <p:spPr>
-          <a:xfrm>
-            <a:off x="6400800" y="3950208"/>
-            <a:ext cx="1234440" cy="256032"/>
-          </a:xfrm>
-          <a:prstGeom prst="rect">
-            <a:avLst/>
-          </a:prstGeom>
-          <a:noFill/>
-          <a:ln/>
-        </p:spPr>
-        <p:txBody>
-          <a:bodyPr wrap="square" lIns="0" tIns="0" rIns="0" bIns="0" rtlCol="0" anchor="ctr"/>
-          <a:lstStyle/>
-          <a:p>
-            <a:pPr algn="ctr" indent="0" marL="0">
-              <a:buNone/>
-            </a:pPr>
-            <a:r>
-              <a:rPr lang="en-US" sz="1000" dirty="0">
-                <a:solidFill>
-                  <a:srgbClr val="5A5470"/>
-                </a:solidFill>
-                <a:latin typeface="Times New Roman" pitchFamily="34" charset="0"/>
-                <a:ea typeface="Times New Roman" pitchFamily="34" charset="-122"/>
-                <a:cs typeface="Times New Roman" pitchFamily="34" charset="-120"/>
-              </a:rPr>
-              <a:t>—</a:t>
-            </a:r>
-            <a:endParaRPr lang="en-US" sz="1000" dirty="0"/>
-          </a:p>
-        </p:txBody>
-      </p:sp>
-      <p:sp>
-        <p:nvSpPr>
-          <p:cNvPr id="70" name="Shape 67"/>
-          <p:cNvSpPr/>
-          <p:nvPr/>
-        </p:nvSpPr>
-        <p:spPr>
-          <a:xfrm>
-            <a:off x="7882128" y="3991356"/>
-            <a:ext cx="694944" cy="173736"/>
-          </a:xfrm>
-          <a:prstGeom prst="roundRect">
-            <a:avLst>
-              <a:gd name="adj" fmla="val 47368"/>
-            </a:avLst>
-          </a:prstGeom>
-          <a:solidFill>
-            <a:srgbClr val="D7D2E9"/>
-          </a:solidFill>
-          <a:ln/>
-        </p:spPr>
-        <p:txBody>
-          <a:bodyPr/>
-          <a:p/>
-        </p:txBody>
-      </p:sp>
-      <p:sp>
-        <p:nvSpPr>
-          <p:cNvPr id="71" name="Text 68"/>
-          <p:cNvSpPr/>
-          <p:nvPr/>
-        </p:nvSpPr>
-        <p:spPr>
-          <a:xfrm>
-            <a:off x="7882128" y="3991356"/>
-            <a:ext cx="694944" cy="173736"/>
-          </a:xfrm>
-          <a:prstGeom prst="rect">
-            <a:avLst/>
-          </a:prstGeom>
-          <a:noFill/>
-          <a:ln/>
-        </p:spPr>
-        <p:txBody>
-          <a:bodyPr wrap="square" lIns="0" tIns="0" rIns="0" bIns="0" rtlCol="0" anchor="ctr"/>
-          <a:lstStyle/>
-          <a:p>
-            <a:pPr algn="ctr" indent="0" marL="0">
-              <a:buNone/>
-            </a:pPr>
-            <a:r>
-              <a:rPr lang="en-US" sz="900" b="1" dirty="0">
-                <a:solidFill>
-                  <a:srgbClr val="5A5470"/>
-                </a:solidFill>
-                <a:latin typeface="Plus Jakarta Sans" pitchFamily="34" charset="0"/>
-                <a:ea typeface="Plus Jakarta Sans" pitchFamily="34" charset="-122"/>
-                <a:cs typeface="Plus Jakarta Sans" pitchFamily="34" charset="-120"/>
-              </a:rPr>
-              <a:t>—</a:t>
-            </a:r>
-            <a:endParaRPr lang="en-US" sz="900" dirty="0"/>
-          </a:p>
-        </p:txBody>
-      </p:sp>
-      <p:sp>
-        <p:nvSpPr>
           <p:cNvPr id="61" name="Shape 58"/>
           <p:cNvSpPr/>
           <p:nvPr/>
         </p:nvSpPr>
         <p:spPr>
           <a:xfrm>
-            <a:off x="320040" y="4370832"/>
+            <a:off x="320040" y="4114800"/>
             <a:ext cx="8503920" cy="502920"/>
           </a:xfrm>
           <a:prstGeom prst="roundRect">
@@ -3408,7 +3148,7 @@
         </p:nvSpPr>
         <p:spPr>
           <a:xfrm>
-            <a:off x="548640" y="4370832"/>
+            <a:off x="548640" y="4114800"/>
             <a:ext cx="8046720" cy="502920"/>
           </a:xfrm>
           <a:prstGeom prst="rect">
@@ -3461,7 +3201,7 @@
                 <a:ea typeface="Plus Jakarta Sans" pitchFamily="34" charset="-122"/>
                 <a:cs typeface="Plus Jakarta Sans" pitchFamily="34" charset="-120"/>
               </a:rPr>
-              <a:t>Actual — / Target — · 5 branches · Clinic basis</a:t>
+              <a:t>Actual — / Target — · 4 branches · Clinic basis</a:t>
             </a:r>
             <a:endParaRPr lang="en-US" sz="1200" dirty="0"/>
           </a:p>

</xml_diff>